<commit_message>
Add volume-weighted average maintainability delta placeholders per metric
Adds PORTFOLIO_MAINT_AVG_DELTA_{parameter} (colored signed numeric delta)
and PORTFOLIO_MAINT_CHANGE_SUMMARY_{parameter} (full sentence) so the
portfolio-metrics report can show the volume-weighted change in each
maintainability submetric, not just the overall rating.

Co-Authored-By: Claude Sonnet 5 <noreply@anthropic.com>
</commit_message>
<xml_diff>
--- a/src/report_generator/presets/templates/portfolio-metrics.pptx
+++ b/src/report_generator/presets/templates/portfolio-metrics.pptx
@@ -336,7 +336,7 @@
           <a:p>
             <a:fld id="{C1255C68-584F-174D-BB81-51BF91708794}" type="datetimeFigureOut">
               <a:rPr lang="en-US" smtClean="0"/>
-              <a:t>9/4/26</a:t>
+              <a:t>9/11/26</a:t>
             </a:fld>
             <a:endParaRPr lang="en-US"/>
           </a:p>
@@ -529,7 +529,7 @@
           <a:p>
             <a:fld id="{A1EDAAC4-819D-C544-9EA1-C73624CFD70B}" type="datetimeFigureOut">
               <a:rPr lang="en-US" smtClean="0"/>
-              <a:t>9/4/26</a:t>
+              <a:t>9/11/26</a:t>
             </a:fld>
             <a:endParaRPr lang="en-US"/>
           </a:p>
@@ -17534,11 +17534,60 @@
           <a:p>
             <a:pPr indent="-283845"/>
             <a:r>
+              <a:rPr lang="en-GB" sz="1550" dirty="0" err="1">
+                <a:ea typeface="Calibri"/>
+                <a:cs typeface="Calibri"/>
+              </a:rPr>
+              <a:t>PORTFOLIO_MAINT_CHANGE_SUMMARY_UNIT_INTERFACING</a:t>
+            </a:r>
+            <a:endParaRPr lang="en-GB" sz="1550" dirty="0">
+              <a:ea typeface="Calibri"/>
+              <a:cs typeface="Calibri"/>
+            </a:endParaRPr>
+          </a:p>
+          <a:p>
+            <a:pPr indent="-283845"/>
+            <a:r>
+              <a:rPr lang="en-GB" sz="1550" dirty="0" err="1">
+                <a:ea typeface="Calibri"/>
+                <a:cs typeface="Calibri"/>
+              </a:rPr>
+              <a:t>PORTFOLIO_MAINT_INCREASED_UNIT_INTERFACING</a:t>
+            </a:r>
+            <a:r>
               <a:rPr lang="en-GB" sz="1550" dirty="0">
                 <a:ea typeface="Calibri"/>
                 <a:cs typeface="Calibri"/>
               </a:rPr>
-              <a:t>PORTFOLIO_MAINT_INCREASED_UNIT_INTERFACING% of systems has seen an increase in their Unit Interfacing rating. PORTFOLIO_MAINT_STABLE_UNIT_INTERFACING% of systems has remained stable. PORTFOLIO_MAINT_DECREASED_UNIT_INTERFACING% of systems has seen a decrease in maintainability.</a:t>
+              <a:t>% of systems has seen an increase in their Unit Interfacing rating. </a:t>
+            </a:r>
+            <a:r>
+              <a:rPr lang="en-GB" sz="1550" dirty="0" err="1">
+                <a:ea typeface="Calibri"/>
+                <a:cs typeface="Calibri"/>
+              </a:rPr>
+              <a:t>PORTFOLIO_MAINT_STABLE_UNIT_INTERFACING</a:t>
+            </a:r>
+            <a:r>
+              <a:rPr lang="en-GB" sz="1550" dirty="0">
+                <a:ea typeface="Calibri"/>
+                <a:cs typeface="Calibri"/>
+              </a:rPr>
+              <a:t>% of systems has remained stable. </a:t>
+            </a:r>
+            <a:r>
+              <a:rPr lang="en-GB" sz="1550" dirty="0" err="1">
+                <a:ea typeface="Calibri"/>
+                <a:cs typeface="Calibri"/>
+              </a:rPr>
+              <a:t>PORTFOLIO_MAINT_DECREASED_UNIT_INTERFACING</a:t>
+            </a:r>
+            <a:r>
+              <a:rPr lang="en-GB" sz="1550" dirty="0">
+                <a:ea typeface="Calibri"/>
+                <a:cs typeface="Calibri"/>
+              </a:rPr>
+              <a:t>% of systems has seen a decrease in maintainability.</a:t>
             </a:r>
           </a:p>
           <a:p>
@@ -19025,11 +19074,46 @@
           <a:p>
             <a:pPr indent="-283845"/>
             <a:r>
+              <a:rPr lang="en-GB" sz="1550" dirty="0" err="1">
+                <a:ea typeface="Calibri"/>
+                <a:cs typeface="Calibri"/>
+              </a:rPr>
+              <a:t>PORTFOLIO_MAINT_CHANGE_SUMMARY_MODULE_COUPLING</a:t>
+            </a:r>
+            <a:endParaRPr lang="en-GB" sz="1550" dirty="0">
+              <a:ea typeface="Calibri"/>
+              <a:cs typeface="Calibri"/>
+            </a:endParaRPr>
+          </a:p>
+          <a:p>
+            <a:pPr indent="-283845"/>
+            <a:r>
+              <a:rPr lang="en-GB" sz="1550" dirty="0" err="1">
+                <a:ea typeface="Calibri"/>
+                <a:cs typeface="Calibri"/>
+              </a:rPr>
+              <a:t>PORTFOLIO_MAINT_INCREASED_MODULE_COUPLING</a:t>
+            </a:r>
+            <a:r>
               <a:rPr lang="en-GB" sz="1550" dirty="0">
                 <a:ea typeface="Calibri"/>
                 <a:cs typeface="Calibri"/>
               </a:rPr>
-              <a:t>PORTFOLIO_MAINT_INCREASED_MODULE_COUPLING% of systems has seen an increase in their Module Coupling rating. PORTFOLIO_MAINT_STABLE_MODULE_COUPLING% of systems has remained stable. PORTFOLIO_MAINT_DECREASED_MODULE_COUPLING% of systems has seen a decrease in maintainability.</a:t>
+              <a:t>% of systems has seen an increase in their Module Coupling rating. </a:t>
+            </a:r>
+            <a:r>
+              <a:rPr lang="en-GB" sz="1550" dirty="0" err="1">
+                <a:ea typeface="Calibri"/>
+                <a:cs typeface="Calibri"/>
+              </a:rPr>
+              <a:t>PORTFOLIO_MAINT_STABLE_MODULE_COUPLING</a:t>
+            </a:r>
+            <a:r>
+              <a:rPr lang="en-GB" sz="1550" dirty="0">
+                <a:ea typeface="Calibri"/>
+                <a:cs typeface="Calibri"/>
+              </a:rPr>
+              <a:t>% of systems has remained stable. PORTFOLIO_MAINT_DECREASED_MODULE_COUPLING% of systems has seen a decrease in maintainability.</a:t>
             </a:r>
           </a:p>
           <a:p>
@@ -20516,11 +20600,46 @@
           <a:p>
             <a:pPr indent="-283845"/>
             <a:r>
+              <a:rPr lang="en-GB" sz="1550" dirty="0" err="1">
+                <a:ea typeface="Calibri"/>
+                <a:cs typeface="Calibri"/>
+              </a:rPr>
+              <a:t>PORTFOLIO_MAINT_CHANGE_SUMMARY_COMPONENT_INDEPENDENCE</a:t>
+            </a:r>
+            <a:endParaRPr lang="en-GB" sz="1550" dirty="0">
+              <a:ea typeface="Calibri"/>
+              <a:cs typeface="Calibri"/>
+            </a:endParaRPr>
+          </a:p>
+          <a:p>
+            <a:pPr indent="-283845"/>
+            <a:r>
+              <a:rPr lang="en-GB" sz="1550" dirty="0" err="1">
+                <a:ea typeface="Calibri"/>
+                <a:cs typeface="Calibri"/>
+              </a:rPr>
+              <a:t>PORTFOLIO_MAINT_INCREASED_COMPONENT_INDEPENDENCE</a:t>
+            </a:r>
+            <a:r>
               <a:rPr lang="en-GB" sz="1550" dirty="0">
                 <a:ea typeface="Calibri"/>
                 <a:cs typeface="Calibri"/>
               </a:rPr>
-              <a:t>PORTFOLIO_MAINT_INCREASED_COMPONENT_INDEPENDENCE% of systems has seen an increase in their Component Independence rating. PORTFOLIO_MAINT_STABLE_COMPONENT_INDEPENDENCE% of systems has remained stable. PORTFOLIO_MAINT_DECREASED_COMPONENT_INDEPENDENCE% of systems has seen a decrease in maintainability.</a:t>
+              <a:t>% of systems has seen an increase in their Component Independence rating. </a:t>
+            </a:r>
+            <a:r>
+              <a:rPr lang="en-GB" sz="1550" dirty="0" err="1">
+                <a:ea typeface="Calibri"/>
+                <a:cs typeface="Calibri"/>
+              </a:rPr>
+              <a:t>PORTFOLIO_MAINT_STABLE_COMPONENT_INDEPENDENCE</a:t>
+            </a:r>
+            <a:r>
+              <a:rPr lang="en-GB" sz="1550" dirty="0">
+                <a:ea typeface="Calibri"/>
+                <a:cs typeface="Calibri"/>
+              </a:rPr>
+              <a:t>% of systems has remained stable. PORTFOLIO_MAINT_DECREASED_COMPONENT_INDEPENDENCE% of systems has seen a decrease in maintainability.</a:t>
             </a:r>
           </a:p>
           <a:p>
@@ -22007,11 +22126,53 @@
           <a:p>
             <a:pPr indent="-283845"/>
             <a:r>
+              <a:rPr lang="en-GB" sz="1550" dirty="0" err="1">
+                <a:ea typeface="Calibri"/>
+                <a:cs typeface="Calibri"/>
+              </a:rPr>
+              <a:t>PORTFOLIO_MAINT_CHANGE_SUMMARY_COMPONENT_ENTANGLEMENT</a:t>
+            </a:r>
+            <a:endParaRPr lang="en-GB" sz="1550" dirty="0">
+              <a:ea typeface="Calibri"/>
+              <a:cs typeface="Calibri"/>
+            </a:endParaRPr>
+          </a:p>
+          <a:p>
+            <a:pPr indent="-283845"/>
+            <a:r>
+              <a:rPr lang="en-GB" sz="1550" dirty="0" err="1">
+                <a:ea typeface="Calibri"/>
+                <a:cs typeface="Calibri"/>
+              </a:rPr>
+              <a:t>PORTFOLIO_MAINT_INCREASED_COMPONENT_ENTANGLEMENT</a:t>
+            </a:r>
+            <a:r>
               <a:rPr lang="en-GB" sz="1550" dirty="0">
                 <a:ea typeface="Calibri"/>
                 <a:cs typeface="Calibri"/>
               </a:rPr>
-              <a:t>PORTFOLIO_MAINT_INCREASED_COMPONENT_ENTANGLEMENT% of systems has seen an increase in their Component Entanglement rating. PORTFOLIO_MAINT_STABLE_COMPONENT_ENTANGLEMENT% of systems has remained stable. PORTFOLIO_MAINT_DECREASED_COMPONENT_ENTANGLEMENT% of systems has seen a decrease in maintainability.</a:t>
+              <a:t>% of systems has seen an increase in their Component Entanglement </a:t>
+            </a:r>
+            <a:r>
+              <a:rPr lang="en-GB" sz="1550">
+                <a:ea typeface="Calibri"/>
+                <a:cs typeface="Calibri"/>
+              </a:rPr>
+              <a:t>rating. PORTFOLIO</a:t>
+            </a:r>
+            <a:r>
+              <a:rPr lang="en-GB" sz="1550" dirty="0" err="1">
+                <a:ea typeface="Calibri"/>
+                <a:cs typeface="Calibri"/>
+              </a:rPr>
+              <a:t>_MAINT_STABLE_COMPONENT_ENTANGLEMENT</a:t>
+            </a:r>
+            <a:r>
+              <a:rPr lang="en-GB" sz="1550" dirty="0">
+                <a:ea typeface="Calibri"/>
+                <a:cs typeface="Calibri"/>
+              </a:rPr>
+              <a:t>% of systems has remained stable. PORTFOLIO_MAINT_DECREASED_COMPONENT_ENTANGLEMENT% of systems has seen a decrease in maintainability.</a:t>
             </a:r>
           </a:p>
           <a:p>
@@ -40131,11 +40292,46 @@
           <a:p>
             <a:pPr indent="-283845"/>
             <a:r>
+              <a:rPr lang="en-GB" sz="1550" dirty="0" err="1">
+                <a:ea typeface="Calibri"/>
+                <a:cs typeface="Calibri"/>
+              </a:rPr>
+              <a:t>PORTFOLIO_MAINT_CHANGE_SUMMARY_DUPLICATION</a:t>
+            </a:r>
+            <a:endParaRPr lang="en-GB" sz="1550" dirty="0">
+              <a:ea typeface="Calibri"/>
+              <a:cs typeface="Calibri"/>
+            </a:endParaRPr>
+          </a:p>
+          <a:p>
+            <a:pPr indent="-283845"/>
+            <a:r>
+              <a:rPr lang="en-GB" sz="1550" dirty="0" err="1">
+                <a:ea typeface="Calibri"/>
+                <a:cs typeface="Calibri"/>
+              </a:rPr>
+              <a:t>PORTFOLIO_MAINT_INCREASED_DUPLICATION</a:t>
+            </a:r>
+            <a:r>
               <a:rPr lang="en-GB" sz="1550" dirty="0">
                 <a:ea typeface="Calibri"/>
                 <a:cs typeface="Calibri"/>
               </a:rPr>
-              <a:t>PORTFOLIO_MAINT_INCREASED_DUPLICATION% of systems has seen an increase in their Duplication rating. PORTFOLIO_MAINT_STABLE_DUPLICATION% of systems has remained stable. PORTFOLIO_MAINT_DECREASED_DUPLICATION% of systems has seen a decrease in maintainability.</a:t>
+              <a:t>% of systems has seen an increase in their Duplication rating. </a:t>
+            </a:r>
+            <a:r>
+              <a:rPr lang="en-GB" sz="1550" dirty="0" err="1">
+                <a:ea typeface="Calibri"/>
+                <a:cs typeface="Calibri"/>
+              </a:rPr>
+              <a:t>PORTFOLIO_MAINT_STABLE_DUPLICATION</a:t>
+            </a:r>
+            <a:r>
+              <a:rPr lang="en-GB" sz="1550" dirty="0">
+                <a:ea typeface="Calibri"/>
+                <a:cs typeface="Calibri"/>
+              </a:rPr>
+              <a:t>% of systems has remained stable. PORTFOLIO_MAINT_DECREASED_DUPLICATION% of systems has seen a decrease in maintainability.</a:t>
             </a:r>
           </a:p>
           <a:p>
@@ -45198,11 +45394,46 @@
           <a:p>
             <a:pPr indent="-283845"/>
             <a:r>
+              <a:rPr lang="en-GB" sz="1550" dirty="0" err="1">
+                <a:ea typeface="Calibri"/>
+                <a:cs typeface="Calibri"/>
+              </a:rPr>
+              <a:t>PORTFOLIO_MAINT_CHANGE_SUMMARY_UNIT_SIZE</a:t>
+            </a:r>
+            <a:endParaRPr lang="en-GB" sz="1550" dirty="0">
+              <a:ea typeface="Calibri"/>
+              <a:cs typeface="Calibri"/>
+            </a:endParaRPr>
+          </a:p>
+          <a:p>
+            <a:pPr indent="-283845"/>
+            <a:r>
+              <a:rPr lang="en-GB" sz="1550" dirty="0" err="1">
+                <a:ea typeface="Calibri"/>
+                <a:cs typeface="Calibri"/>
+              </a:rPr>
+              <a:t>PORTFOLIO_MAINT_INCREASED_UNIT_SIZE</a:t>
+            </a:r>
+            <a:r>
               <a:rPr lang="en-GB" sz="1550" dirty="0">
                 <a:ea typeface="Calibri"/>
                 <a:cs typeface="Calibri"/>
               </a:rPr>
-              <a:t>PORTFOLIO_MAINT_INCREASED_UNIT_SIZE% of systems has seen an increase in their Unit Size rating. PORTFOLIO_MAINT_STABLE_UNIT_SIZE% of systems has remained stable. PORTFOLIO_MAINT_DECREASED_UNIT_SIZE% of systems has seen a decrease in maintainability.</a:t>
+              <a:t>% of systems has seen an increase in their Unit Size rating. </a:t>
+            </a:r>
+            <a:r>
+              <a:rPr lang="en-GB" sz="1550" dirty="0" err="1">
+                <a:ea typeface="Calibri"/>
+                <a:cs typeface="Calibri"/>
+              </a:rPr>
+              <a:t>PORTFOLIO_MAINT_STABLE_UNIT_SIZE</a:t>
+            </a:r>
+            <a:r>
+              <a:rPr lang="en-GB" sz="1550" dirty="0">
+                <a:ea typeface="Calibri"/>
+                <a:cs typeface="Calibri"/>
+              </a:rPr>
+              <a:t>% of systems has remained stable. PORTFOLIO_MAINT_DECREASED_UNIT_SIZE% of systems has seen a decrease in maintainability.</a:t>
             </a:r>
           </a:p>
           <a:p>
@@ -46689,11 +46920,46 @@
           <a:p>
             <a:pPr indent="-283845"/>
             <a:r>
+              <a:rPr lang="en-GB" sz="1550" dirty="0" err="1">
+                <a:ea typeface="Calibri"/>
+                <a:cs typeface="Calibri"/>
+              </a:rPr>
+              <a:t>PORTFOLIO_MAINT_CHANGE_SUMMARY_UNIT_COMPLEXITY</a:t>
+            </a:r>
+            <a:endParaRPr lang="en-GB" sz="1550" dirty="0">
+              <a:ea typeface="Calibri"/>
+              <a:cs typeface="Calibri"/>
+            </a:endParaRPr>
+          </a:p>
+          <a:p>
+            <a:pPr indent="-283845"/>
+            <a:r>
+              <a:rPr lang="en-GB" sz="1550" dirty="0" err="1">
+                <a:ea typeface="Calibri"/>
+                <a:cs typeface="Calibri"/>
+              </a:rPr>
+              <a:t>PORTFOLIO_MAINT_INCREASED_UNIT_COMPLEXITY</a:t>
+            </a:r>
+            <a:r>
               <a:rPr lang="en-GB" sz="1550" dirty="0">
                 <a:ea typeface="Calibri"/>
                 <a:cs typeface="Calibri"/>
               </a:rPr>
-              <a:t>PORTFOLIO_MAINT_INCREASED_UNIT_COMPLEXITY% of systems has seen an increase in their Unit Complexity rating. PORTFOLIO_MAINT_STABLE_UNIT_COMPLEXITY% of systems has remained stable. PORTFOLIO_MAINT_DECREASED_UNIT_COMPLEXITY% of systems has seen a decrease in maintainability.</a:t>
+              <a:t>% of systems has seen an increase in their Unit Complexity rating. </a:t>
+            </a:r>
+            <a:r>
+              <a:rPr lang="en-GB" sz="1550" dirty="0" err="1">
+                <a:ea typeface="Calibri"/>
+                <a:cs typeface="Calibri"/>
+              </a:rPr>
+              <a:t>PORTFOLIO_MAINT_STABLE_UNIT_COMPLEXITY</a:t>
+            </a:r>
+            <a:r>
+              <a:rPr lang="en-GB" sz="1550" dirty="0">
+                <a:ea typeface="Calibri"/>
+                <a:cs typeface="Calibri"/>
+              </a:rPr>
+              <a:t>% of systems has remained stable. PORTFOLIO_MAINT_DECREASED_UNIT_COMPLEXITY% of systems has seen a decrease in maintainability.</a:t>
             </a:r>
           </a:p>
           <a:p>
@@ -48862,6 +49128,15 @@
 </file>
 
 <file path=customXml/item1.xml><?xml version="1.0" encoding="utf-8"?>
+<?mso-contentType ?>
+<FormTemplates xmlns="http://schemas.microsoft.com/sharepoint/v3/contenttype/forms">
+  <Display>DocumentLibraryForm</Display>
+  <Edit>DocumentLibraryForm</Edit>
+  <New>DocumentLibraryForm</New>
+</FormTemplates>
+</file>
+
+<file path=customXml/item2.xml><?xml version="1.0" encoding="utf-8"?>
 <ct:contentTypeSchema xmlns:ct="http://schemas.microsoft.com/office/2006/metadata/contentType" xmlns:ma="http://schemas.microsoft.com/office/2006/metadata/properties/metaAttributes" ct:_="" ma:_="" ma:contentTypeName="Document" ma:contentTypeID="0x0101004DEF897B6A9E5243A3BAB7B7BDA55B95" ma:contentTypeVersion="3" ma:contentTypeDescription="Een nieuw document maken." ma:contentTypeScope="" ma:versionID="0a97628efbdf127f23042160181f1d9a">
   <xsd:schema xmlns:xsd="http://www.w3.org/2001/XMLSchema" xmlns:xs="http://www.w3.org/2001/XMLSchema" xmlns:p="http://schemas.microsoft.com/office/2006/metadata/properties" xmlns:ns2="444ebd02-7183-4d1c-abe9-f175efe83725" targetNamespace="http://schemas.microsoft.com/office/2006/metadata/properties" ma:root="true" ma:fieldsID="44a7a3b93c857102c842f6fb1da07824" ns2:_="">
     <xsd:import namespace="444ebd02-7183-4d1c-abe9-f175efe83725"/>
@@ -48999,22 +49274,21 @@
 </ct:contentTypeSchema>
 </file>
 
-<file path=customXml/item2.xml><?xml version="1.0" encoding="utf-8"?>
+<file path=customXml/item3.xml><?xml version="1.0" encoding="utf-8"?>
 <p:properties xmlns:p="http://schemas.microsoft.com/office/2006/metadata/properties" xmlns:xsi="http://www.w3.org/2001/XMLSchema-instance" xmlns:pc="http://schemas.microsoft.com/office/infopath/2007/PartnerControls">
   <documentManagement/>
 </p:properties>
 </file>
 
-<file path=customXml/item3.xml><?xml version="1.0" encoding="utf-8"?>
-<?mso-contentType ?>
-<FormTemplates xmlns="http://schemas.microsoft.com/sharepoint/v3/contenttype/forms">
-  <Display>DocumentLibraryForm</Display>
-  <Edit>DocumentLibraryForm</Edit>
-  <New>DocumentLibraryForm</New>
-</FormTemplates>
+<file path=customXml/itemProps1.xml><?xml version="1.0" encoding="utf-8"?>
+<ds:datastoreItem xmlns:ds="http://schemas.openxmlformats.org/officeDocument/2006/customXml" ds:itemID="{88AD9160-B56A-4FCD-857D-8AE63521E7FB}">
+  <ds:schemaRefs>
+    <ds:schemaRef ds:uri="http://schemas.microsoft.com/sharepoint/v3/contenttype/forms"/>
+  </ds:schemaRefs>
+</ds:datastoreItem>
 </file>
 
-<file path=customXml/itemProps1.xml><?xml version="1.0" encoding="utf-8"?>
+<file path=customXml/itemProps2.xml><?xml version="1.0" encoding="utf-8"?>
 <ds:datastoreItem xmlns:ds="http://schemas.openxmlformats.org/officeDocument/2006/customXml" ds:itemID="{3AFAF3E6-8A11-4BDC-9823-6F0ACEBB33D3}">
   <ds:schemaRefs>
     <ds:schemaRef ds:uri="http://schemas.microsoft.com/office/2006/metadata/contentType"/>
@@ -49032,7 +49306,7 @@
 </ds:datastoreItem>
 </file>
 
-<file path=customXml/itemProps2.xml><?xml version="1.0" encoding="utf-8"?>
+<file path=customXml/itemProps3.xml><?xml version="1.0" encoding="utf-8"?>
 <ds:datastoreItem xmlns:ds="http://schemas.openxmlformats.org/officeDocument/2006/customXml" ds:itemID="{7575A4A2-8818-4F4B-AD30-88D568004514}">
   <ds:schemaRefs>
     <ds:schemaRef ds:uri="http://schemas.microsoft.com/office/2006/metadata/properties"/>
@@ -49046,12 +49320,4 @@
     <ds:schemaRef ds:uri="http://purl.org/dc/dcmitype/"/>
   </ds:schemaRefs>
 </ds:datastoreItem>
-</file>
-
-<file path=customXml/itemProps3.xml><?xml version="1.0" encoding="utf-8"?>
-<ds:datastoreItem xmlns:ds="http://schemas.openxmlformats.org/officeDocument/2006/customXml" ds:itemID="{88AD9160-B56A-4FCD-857D-8AE63521E7FB}">
-  <ds:schemaRefs>
-    <ds:schemaRef ds:uri="http://schemas.microsoft.com/sharepoint/v3/contenttype/forms"/>
-  </ds:schemaRefs>
-</ds:datastoreItem>
 </file>
</xml_diff>